<commit_message>
Added thesis and report
</commit_message>
<xml_diff>
--- a/docs/submissions/GROUP-E_ppt.pptx
+++ b/docs/submissions/GROUP-E_ppt.pptx
@@ -2232,7 +2232,7 @@
         <p:spPr>
           <a:xfrm>
             <a:off x="822960" y="1143000"/>
-            <a:ext cx="10241280" cy="1920240"/>
+            <a:ext cx="10241280" cy="2170240"/>
           </a:xfrm>
           <a:prstGeom prst="rect">
             <a:avLst/>
@@ -2251,7 +2251,7 @@
               <a:buNone/>
             </a:pPr>
             <a:r>
-              <a:rPr lang="en-US" sz="4000" b="1" dirty="0">
+              <a:rPr lang="en-US" sz="3000" b="1" dirty="0">
                 <a:solidFill>
                   <a:srgbClr val="FFFFFF"/>
                 </a:solidFill>
@@ -2259,9 +2259,9 @@
                 <a:ea typeface="Cambria" pitchFamily="34" charset="-122"/>
                 <a:cs typeface="Cambria" pitchFamily="34" charset="-120"/>
               </a:rPr>
-              <a:t>Hybrid Telecom Stream</a:t>
-            </a:r>
-            <a:endParaRPr lang="en-US" sz="4000" dirty="0"/>
+              <a:t>DATA ANALYSIS OF STREAMING TELECOM</a:t>
+            </a:r>
+            <a:endParaRPr lang="en-US" sz="3000" dirty="0"/>
           </a:p>
           <a:p>
             <a:pPr indent="0" marL="0">
@@ -2271,7 +2271,7 @@
               <a:buNone/>
             </a:pPr>
             <a:r>
-              <a:rPr lang="en-US" sz="4000" b="1" dirty="0">
+              <a:rPr lang="en-US" sz="3000" b="1" dirty="0">
                 <a:solidFill>
                   <a:srgbClr val="FFFFFF"/>
                 </a:solidFill>
@@ -2279,9 +2279,29 @@
                 <a:ea typeface="Cambria" pitchFamily="34" charset="-122"/>
                 <a:cs typeface="Cambria" pitchFamily="34" charset="-120"/>
               </a:rPr>
-              <a:t>Processing Framework</a:t>
-            </a:r>
-            <a:endParaRPr lang="en-US" sz="4000" dirty="0"/>
+              <a:t>TRAFFIC DATA USING DATA EXTRACTION</a:t>
+            </a:r>
+            <a:endParaRPr lang="en-US" sz="3000" dirty="0"/>
+          </a:p>
+          <a:p>
+            <a:pPr indent="0" marL="0">
+              <a:lnSpc>
+                <a:spcPct val="105000"/>
+              </a:lnSpc>
+              <a:buNone/>
+            </a:pPr>
+            <a:r>
+              <a:rPr lang="en-US" sz="3000" b="1" dirty="0">
+                <a:solidFill>
+                  <a:srgbClr val="FFFFFF"/>
+                </a:solidFill>
+                <a:latin typeface="Cambria" pitchFamily="34" charset="0"/>
+                <a:ea typeface="Cambria" pitchFamily="34" charset="-122"/>
+                <a:cs typeface="Cambria" pitchFamily="34" charset="-120"/>
+              </a:rPr>
+              <a:t>SERVER IN A MESSAGE PASSING ENVIRONMENT</a:t>
+            </a:r>
+            <a:endParaRPr lang="en-US" sz="3000" dirty="0"/>
           </a:p>
         </p:txBody>
       </p:sp>
@@ -2293,7 +2313,7 @@
         </p:nvSpPr>
         <p:spPr>
           <a:xfrm>
-            <a:off x="822960" y="3063240"/>
+            <a:off x="822960" y="3313240"/>
             <a:ext cx="9875520" cy="548640"/>
           </a:xfrm>
           <a:prstGeom prst="rect">
@@ -2332,7 +2352,7 @@
         </p:nvSpPr>
         <p:spPr>
           <a:xfrm>
-            <a:off x="822960" y="3977640"/>
+            <a:off x="822960" y="4227640"/>
             <a:ext cx="2011680" cy="0"/>
           </a:xfrm>
           <a:prstGeom prst="line">
@@ -2355,7 +2375,7 @@
         </p:nvSpPr>
         <p:spPr>
           <a:xfrm>
-            <a:off x="822960" y="4160520"/>
+            <a:off x="822960" y="4410520"/>
             <a:ext cx="10058400" cy="365760"/>
           </a:xfrm>
           <a:prstGeom prst="rect">
@@ -2394,89 +2414,64 @@
                 <a:ea typeface="Calibri" pitchFamily="34" charset="-122"/>
                 <a:cs typeface="Calibri" pitchFamily="34" charset="-120"/>
               </a:rPr>
-              <a:t>Pathi Jahnavi</a:t>
+              <a:t>Pathi Jahnavi (2023UCP1595)</a:t>
             </a:r>
             <a:pPr indent="0" marL="0">
               <a:buNone/>
             </a:pPr>
             <a:r>
-              <a:rPr lang="en-US" sz="1300" dirty="0">
-                <a:solidFill>
-                  <a:srgbClr val="9FB3C8"/>
+              <a:rPr lang="en-US" sz="1100" i="1" dirty="0">
+                <a:solidFill>
+                  <a:srgbClr val="00C2CB"/>
                 </a:solidFill>
                 <a:latin typeface="Calibri" pitchFamily="34" charset="0"/>
                 <a:ea typeface="Calibri" pitchFamily="34" charset="-122"/>
                 <a:cs typeface="Calibri" pitchFamily="34" charset="-120"/>
               </a:rPr>
-              <a:t>   &amp;   </a:t>
+              <a:t> — Team Lead</a:t>
             </a:r>
             <a:pPr indent="0" marL="0">
               <a:buNone/>
             </a:pPr>
             <a:r>
-              <a:rPr lang="en-US" sz="1300" b="1" dirty="0">
-                <a:solidFill>
-                  <a:srgbClr val="FFFFFF"/>
+              <a:rPr lang="en-US" sz="1300" dirty="0">
+                <a:solidFill>
+                  <a:srgbClr val="9FB3C8"/>
                 </a:solidFill>
                 <a:latin typeface="Calibri" pitchFamily="34" charset="0"/>
                 <a:ea typeface="Calibri" pitchFamily="34" charset="-122"/>
                 <a:cs typeface="Calibri" pitchFamily="34" charset="-120"/>
               </a:rPr>
-              <a:t>Katta Sreeja Meharani</a:t>
-            </a:r>
-            <a:endParaRPr lang="en-US" sz="1300" dirty="0"/>
-          </a:p>
-        </p:txBody>
-      </p:sp>
-      <p:sp>
-        <p:nvSpPr>
-          <p:cNvPr id="9" name="Text 7"/>
-          <p:cNvSpPr/>
-          <p:nvPr/>
-        </p:nvSpPr>
-        <p:spPr>
-          <a:xfrm>
-            <a:off x="822960" y="4498848"/>
-            <a:ext cx="10058400" cy="320040"/>
-          </a:xfrm>
-          <a:prstGeom prst="rect">
-            <a:avLst/>
-          </a:prstGeom>
-          <a:noFill/>
-          <a:ln/>
-        </p:spPr>
-        <p:txBody>
-          <a:bodyPr wrap="square" rtlCol="0" anchor="ctr"/>
-          <a:lstStyle/>
-          <a:p>
+              <a:t>   ·   </a:t>
+            </a:r>
             <a:pPr indent="0" marL="0">
               <a:buNone/>
             </a:pPr>
             <a:r>
               <a:rPr lang="en-US" sz="1200" i="1" dirty="0">
                 <a:solidFill>
-                  <a:srgbClr val="9FB3C8"/>
+                  <a:srgbClr val="CADCFC"/>
                 </a:solidFill>
                 <a:latin typeface="Calibri" pitchFamily="34" charset="0"/>
                 <a:ea typeface="Calibri" pitchFamily="34" charset="-122"/>
                 <a:cs typeface="Calibri" pitchFamily="34" charset="-120"/>
               </a:rPr>
-              <a:t>MNIT Jaipur   ·   GNITS Hyderabad</a:t>
-            </a:r>
-            <a:endParaRPr lang="en-US" sz="1200" dirty="0"/>
-          </a:p>
-        </p:txBody>
-      </p:sp>
-      <p:sp>
-        <p:nvSpPr>
-          <p:cNvPr id="10" name="Text 8"/>
-          <p:cNvSpPr/>
-          <p:nvPr/>
-        </p:nvSpPr>
-        <p:spPr>
-          <a:xfrm>
-            <a:off x="822960" y="4983480"/>
-            <a:ext cx="10058400" cy="320040"/>
+              <a:t>MNIT Jaipur</a:t>
+            </a:r>
+            <a:endParaRPr lang="en-US" sz="1300" dirty="0"/>
+          </a:p>
+        </p:txBody>
+      </p:sp>
+      <p:sp>
+        <p:nvSpPr>
+          <p:cNvPr id="9" name="Text 7"/>
+          <p:cNvSpPr/>
+          <p:nvPr/>
+        </p:nvSpPr>
+        <p:spPr>
+          <a:xfrm>
+            <a:off x="822960" y="4748848"/>
+            <a:ext cx="10058400" cy="365760"/>
           </a:xfrm>
           <a:prstGeom prst="rect">
             <a:avLst/>
@@ -2492,67 +2487,134 @@
               <a:buNone/>
             </a:pPr>
             <a:r>
-              <a:rPr lang="en-US" sz="1300" dirty="0">
-                <a:solidFill>
-                  <a:srgbClr val="9FB3C8"/>
+              <a:rPr lang="en-US" sz="1300" b="1" dirty="0">
+                <a:solidFill>
+                  <a:srgbClr val="FFFFFF"/>
                 </a:solidFill>
                 <a:latin typeface="Calibri" pitchFamily="34" charset="0"/>
                 <a:ea typeface="Calibri" pitchFamily="34" charset="-122"/>
                 <a:cs typeface="Calibri" pitchFamily="34" charset="-120"/>
               </a:rPr>
-              <a:t>Project Guidance   </a:t>
+              <a:t>Katta Sreeja Meharani (23251A6750)</a:t>
             </a:r>
             <a:pPr indent="0" marL="0">
               <a:buNone/>
             </a:pPr>
             <a:r>
-              <a:rPr lang="en-US" sz="1300" b="1" dirty="0">
-                <a:solidFill>
-                  <a:srgbClr val="FFFFFF"/>
+              <a:rPr lang="en-US" sz="1300" dirty="0">
+                <a:solidFill>
+                  <a:srgbClr val="9FB3C8"/>
                 </a:solidFill>
                 <a:latin typeface="Calibri" pitchFamily="34" charset="0"/>
                 <a:ea typeface="Calibri" pitchFamily="34" charset="-122"/>
                 <a:cs typeface="Calibri" pitchFamily="34" charset="-120"/>
               </a:rPr>
-              <a:t>Dr. V. C. V. Rao</a:t>
-            </a:r>
-            <a:endParaRPr lang="en-US" sz="1300" dirty="0"/>
-          </a:p>
-        </p:txBody>
-      </p:sp>
-      <p:sp>
-        <p:nvSpPr>
-          <p:cNvPr id="11" name="Text 9"/>
-          <p:cNvSpPr/>
-          <p:nvPr/>
-        </p:nvSpPr>
-        <p:spPr>
-          <a:xfrm>
-            <a:off x="822960" y="5303520"/>
-            <a:ext cx="10058400" cy="320040"/>
-          </a:xfrm>
-          <a:prstGeom prst="rect">
-            <a:avLst/>
-          </a:prstGeom>
-          <a:noFill/>
-          <a:ln/>
-        </p:spPr>
-        <p:txBody>
-          <a:bodyPr wrap="square" rtlCol="0" anchor="ctr"/>
-          <a:lstStyle/>
-          <a:p>
+              <a:t>   ·   </a:t>
+            </a:r>
             <a:pPr indent="0" marL="0">
               <a:buNone/>
             </a:pPr>
             <a:r>
               <a:rPr lang="en-US" sz="1200" i="1" dirty="0">
                 <a:solidFill>
-                  <a:srgbClr val="9FB3C8"/>
+                  <a:srgbClr val="CADCFC"/>
                 </a:solidFill>
                 <a:latin typeface="Calibri" pitchFamily="34" charset="0"/>
                 <a:ea typeface="Calibri" pitchFamily="34" charset="-122"/>
                 <a:cs typeface="Calibri" pitchFamily="34" charset="-120"/>
               </a:rPr>
+              <a:t>GNITS Hyderabad</a:t>
+            </a:r>
+            <a:endParaRPr lang="en-US" sz="1300" dirty="0"/>
+          </a:p>
+        </p:txBody>
+      </p:sp>
+      <p:sp>
+        <p:nvSpPr>
+          <p:cNvPr id="10" name="Text 8"/>
+          <p:cNvSpPr/>
+          <p:nvPr/>
+        </p:nvSpPr>
+        <p:spPr>
+          <a:xfrm>
+            <a:off x="822960" y="5279200"/>
+            <a:ext cx="10058400" cy="320040"/>
+          </a:xfrm>
+          <a:prstGeom prst="rect">
+            <a:avLst/>
+          </a:prstGeom>
+          <a:noFill/>
+          <a:ln/>
+        </p:spPr>
+        <p:txBody>
+          <a:bodyPr wrap="square" rtlCol="0" anchor="ctr"/>
+          <a:lstStyle/>
+          <a:p>
+            <a:pPr indent="0" marL="0">
+              <a:buNone/>
+            </a:pPr>
+            <a:r>
+              <a:rPr lang="en-US" sz="1300" dirty="0">
+                <a:solidFill>
+                  <a:srgbClr val="9FB3C8"/>
+                </a:solidFill>
+                <a:latin typeface="Calibri" pitchFamily="34" charset="0"/>
+                <a:ea typeface="Calibri" pitchFamily="34" charset="-122"/>
+                <a:cs typeface="Calibri" pitchFamily="34" charset="-120"/>
+              </a:rPr>
+              <a:t>Project Guidance   </a:t>
+            </a:r>
+            <a:pPr indent="0" marL="0">
+              <a:buNone/>
+            </a:pPr>
+            <a:r>
+              <a:rPr lang="en-US" sz="1300" b="1" dirty="0">
+                <a:solidFill>
+                  <a:srgbClr val="FFFFFF"/>
+                </a:solidFill>
+                <a:latin typeface="Calibri" pitchFamily="34" charset="0"/>
+                <a:ea typeface="Calibri" pitchFamily="34" charset="-122"/>
+                <a:cs typeface="Calibri" pitchFamily="34" charset="-120"/>
+              </a:rPr>
+              <a:t>MPPLAB (NSM Project) Experts</a:t>
+            </a:r>
+            <a:endParaRPr lang="en-US" sz="1300" dirty="0"/>
+          </a:p>
+        </p:txBody>
+      </p:sp>
+      <p:sp>
+        <p:nvSpPr>
+          <p:cNvPr id="11" name="Text 9"/>
+          <p:cNvSpPr/>
+          <p:nvPr/>
+        </p:nvSpPr>
+        <p:spPr>
+          <a:xfrm>
+            <a:off x="822960" y="5599240"/>
+            <a:ext cx="10058400" cy="320040"/>
+          </a:xfrm>
+          <a:prstGeom prst="rect">
+            <a:avLst/>
+          </a:prstGeom>
+          <a:noFill/>
+          <a:ln/>
+        </p:spPr>
+        <p:txBody>
+          <a:bodyPr wrap="square" rtlCol="0" anchor="ctr"/>
+          <a:lstStyle/>
+          <a:p>
+            <a:pPr indent="0" marL="0">
+              <a:buNone/>
+            </a:pPr>
+            <a:r>
+              <a:rPr lang="en-US" sz="1200" i="1" dirty="0">
+                <a:solidFill>
+                  <a:srgbClr val="9FB3C8"/>
+                </a:solidFill>
+                <a:latin typeface="Calibri" pitchFamily="34" charset="0"/>
+                <a:ea typeface="Calibri" pitchFamily="34" charset="-122"/>
+                <a:cs typeface="Calibri" pitchFamily="34" charset="-120"/>
+              </a:rPr>
               <a:t>Centre for Development of Advanced Computing (C-DAC), Pune — MPPLAB</a:t>
             </a:r>
             <a:endParaRPr lang="en-US" sz="1200" dirty="0"/>
@@ -2567,7 +2629,7 @@
         </p:nvSpPr>
         <p:spPr>
           <a:xfrm>
-            <a:off x="822960" y="6126480"/>
+            <a:off x="822960" y="6422200"/>
             <a:ext cx="4572000" cy="320040"/>
           </a:xfrm>
           <a:prstGeom prst="rect">
@@ -4200,54 +4262,107 @@
               <a:buNone/>
             </a:pPr>
             <a:r>
-              <a:rPr lang="en-US" sz="1300" dirty="0">
-                <a:solidFill>
-                  <a:srgbClr val="9FB3C8"/>
+              <a:rPr lang="en-US" sz="1300" b="1" dirty="0">
+                <a:solidFill>
+                  <a:srgbClr val="FFFFFF"/>
                 </a:solidFill>
                 <a:latin typeface="Calibri" pitchFamily="34" charset="0"/>
                 <a:ea typeface="Calibri" pitchFamily="34" charset="-122"/>
                 <a:cs typeface="Calibri" pitchFamily="34" charset="-120"/>
               </a:rPr>
-              <a:t>Pathi Jahnavi   ·   Katta Sreeja Meharani</a:t>
-            </a:r>
-            <a:endParaRPr lang="en-US" sz="1300" dirty="0"/>
-          </a:p>
-        </p:txBody>
-      </p:sp>
-      <p:sp>
-        <p:nvSpPr>
-          <p:cNvPr id="7" name="Text 5"/>
-          <p:cNvSpPr/>
-          <p:nvPr/>
-        </p:nvSpPr>
-        <p:spPr>
-          <a:xfrm>
-            <a:off x="822960" y="4919472"/>
-            <a:ext cx="8229600" cy="365760"/>
-          </a:xfrm>
-          <a:prstGeom prst="rect">
-            <a:avLst/>
-          </a:prstGeom>
-          <a:noFill/>
-          <a:ln/>
-        </p:spPr>
-        <p:txBody>
-          <a:bodyPr wrap="square" rtlCol="0" anchor="ctr"/>
-          <a:lstStyle/>
-          <a:p>
+              <a:t>Pathi Jahnavi (2023UCP1595)</a:t>
+            </a:r>
             <a:pPr indent="0" marL="0">
               <a:buNone/>
             </a:pPr>
             <a:r>
-              <a:rPr lang="en-US" sz="1300" dirty="0">
-                <a:solidFill>
-                  <a:srgbClr val="9FB3C8"/>
+              <a:rPr lang="en-US" sz="1100" i="1" dirty="0">
+                <a:solidFill>
+                  <a:srgbClr val="00C2CB"/>
                 </a:solidFill>
                 <a:latin typeface="Calibri" pitchFamily="34" charset="0"/>
                 <a:ea typeface="Calibri" pitchFamily="34" charset="-122"/>
                 <a:cs typeface="Calibri" pitchFamily="34" charset="-120"/>
               </a:rPr>
-              <a:t>Guided by Dr. V. C. V. Rao  —  MPPLAB, C-DAC Pune</a:t>
+              <a:t> — Team Lead</a:t>
+            </a:r>
+            <a:endParaRPr lang="en-US" sz="1300" dirty="0"/>
+          </a:p>
+        </p:txBody>
+      </p:sp>
+      <p:sp>
+        <p:nvSpPr>
+          <p:cNvPr id="13" name="Text 4b"/>
+          <p:cNvSpPr/>
+          <p:nvPr/>
+        </p:nvSpPr>
+        <p:spPr>
+          <a:xfrm>
+            <a:off x="822960" y="4937760"/>
+            <a:ext cx="8229600" cy="365760"/>
+          </a:xfrm>
+          <a:prstGeom prst="rect">
+            <a:avLst/>
+          </a:prstGeom>
+          <a:noFill/>
+          <a:ln/>
+        </p:spPr>
+        <p:txBody>
+          <a:bodyPr wrap="square" rtlCol="0" anchor="ctr"/>
+          <a:lstStyle/>
+          <a:p>
+            <a:pPr indent="0" marL="0">
+              <a:buNone/>
+            </a:pPr>
+            <a:r>
+              <a:rPr lang="en-US" sz="1300" b="1" dirty="0">
+                <a:solidFill>
+                  <a:srgbClr val="FFFFFF"/>
+                </a:solidFill>
+                <a:latin typeface="Calibri" pitchFamily="34" charset="0"/>
+                <a:ea typeface="Calibri" pitchFamily="34" charset="-122"/>
+                <a:cs typeface="Calibri" pitchFamily="34" charset="-120"/>
+              </a:rPr>
+              <a:t>Katta Sreeja Meharani (23251A6750)</a:t>
+            </a:r>
+            <a:endParaRPr lang="en-US" sz="1300" dirty="0"/>
+          </a:p>
+        </p:txBody>
+      </p:sp>
+      <p:sp>
+        <p:nvSpPr>
+          <p:cNvPr id="7" name="Text 5"/>
+          <p:cNvSpPr/>
+          <p:nvPr/>
+        </p:nvSpPr>
+        <p:spPr>
+          <a:xfrm>
+            <a:off x="822960" y="5350000"/>
+            <a:ext cx="8229600" cy="365760"/>
+          </a:xfrm>
+          <a:prstGeom prst="rect">
+            <a:avLst/>
+          </a:prstGeom>
+          <a:noFill/>
+          <a:ln/>
+        </p:spPr>
+        <p:txBody>
+          <a:bodyPr wrap="square" rtlCol="0" anchor="ctr"/>
+          <a:lstStyle/>
+          <a:p>
+            <a:pPr indent="0" marL="0">
+              <a:buNone/>
+            </a:pPr>
+            <a:r>
+              <a:rPr lang="en-US" sz="1300" dirty="0">
+                <a:solidFill>
+                  <a:srgbClr val="9FB3C8"/>
+                </a:solidFill>
+                <a:latin typeface="Calibri" pitchFamily="34" charset="0"/>
+                <a:ea typeface="Calibri" pitchFamily="34" charset="-122"/>
+                <a:cs typeface="Calibri" pitchFamily="34" charset="-120"/>
+              </a:rPr>
+              <a:t>Guided by MPPLAB (NSM Project) Experts  —  C-DAC, Pune</a:t>
             </a:r>
             <a:endParaRPr lang="en-US" sz="1300" dirty="0"/>
           </a:p>

</xml_diff>